<commit_message>
Refresh Jobseeker v3 introduction deck
Co-authored-by: Copilot App <223556219+Copilot@users.noreply.github.com>
</commit_message>
<xml_diff>
--- a/slides/jobseeker-v3-intro.pptx
+++ b/slides/jobseeker-v3-intro.pptx
@@ -17,6 +17,7 @@
     <p:sldId id="262" r:id="R5f3805d8b71740a3"/>
     <p:sldId id="263" r:id="R418424a4f6a54ad1"/>
     <p:sldId id="264" r:id="R61d5b40ab64c4571"/>
+    <p:sldId id="265" r:id="Rf1589430b60c442e"/>
   </p:sldIdLst>
   <p:sldSz cx="12192000" cy="6858000"/>
   <p:notesSz cx="6858000" cy="9144000"/>
@@ -492,6 +493,61 @@
 </p:notes>
 </file>
 
+<file path=ppt/notesSlides/notesSlide10.xml><?xml version="1.0" encoding="utf-8"?>
+<p:notes xmlns:a="http://schemas.openxmlformats.org/drawingml/2006/main" xmlns:p="http://schemas.openxmlformats.org/presentationml/2006/main">
+  <p:cSld>
+    <p:spTree>
+      <p:nvGrpSpPr>
+        <p:cNvPr id="1" name=""/>
+        <p:cNvGrpSpPr/>
+        <p:nvPr/>
+      </p:nvGrpSpPr>
+      <p:grpSpPr>
+        <a:xfrm xmlns:a="http://schemas.openxmlformats.org/drawingml/2006/main"/>
+      </p:grpSpPr>
+      <p:sp>
+        <p:nvSpPr>
+          <p:cNvPr id="2" name="Slide Image Placeholder 1"/>
+          <p:cNvSpPr/>
+          <p:nvPr>
+            <p:ph type="sldImg" idx="0"/>
+          </p:nvPr>
+        </p:nvSpPr>
+        <p:spPr/>
+        <p:txBody>
+          <a:bodyPr xmlns:a="http://schemas.openxmlformats.org/drawingml/2006/main"/>
+          <a:lstStyle xmlns:a="http://schemas.openxmlformats.org/drawingml/2006/main"/>
+          <a:p xmlns:a="http://schemas.openxmlformats.org/drawingml/2006/main"/>
+        </p:txBody>
+      </p:sp>
+      <p:sp>
+        <p:nvSpPr>
+          <p:cNvPr id="3" name="Notes Placeholder 2"/>
+          <p:cNvSpPr/>
+          <p:nvPr>
+            <p:ph type="body" idx="1"/>
+          </p:nvPr>
+        </p:nvSpPr>
+        <p:spPr/>
+        <p:txBody>
+          <a:bodyPr xmlns:a="http://schemas.openxmlformats.org/drawingml/2006/main"/>
+          <a:lstStyle xmlns:a="http://schemas.openxmlformats.org/drawingml/2006/main"/>
+          <a:p>
+            <a:r>
+              <a:rPr lang="en-US"/>
+              <a:t>Close with the promise: a faster application workflow without giving up evidence or control.</a:t>
+            </a:r>
+          </a:p>
+        </p:txBody>
+      </p:sp>
+    </p:spTree>
+  </p:cSld>
+  <p:clrMapOvr>
+    <a:masterClrMapping xmlns:a="http://schemas.openxmlformats.org/drawingml/2006/main"/>
+  </p:clrMapOvr>
+</p:notes>
+</file>
+
 <file path=ppt/notesSlides/notesSlide2.xml><?xml version="1.0" encoding="utf-8"?>
 <p:notes xmlns:a="http://schemas.openxmlformats.org/drawingml/2006/main" xmlns:p="http://schemas.openxmlformats.org/presentationml/2006/main">
   <p:cSld>
@@ -806,10 +862,10 @@
         <p:txBody>
           <a:bodyPr xmlns:a="http://schemas.openxmlformats.org/drawingml/2006/main"/>
           <a:lstStyle xmlns:a="http://schemas.openxmlformats.org/drawingml/2006/main"/>
-          <a:p xmlns:a="http://schemas.openxmlformats.org/drawingml/2006/main">
+          <a:p>
             <a:r>
               <a:rPr lang="en-US"/>
-              <a:t>This copy uses the GitHub Copilot SDK and a local-first workflow for tailored Danish and English documents.</a:t>
+              <a:t>Editable prompts and the thinking trace make the workflow transparent and adaptable.</a:t>
             </a:r>
           </a:p>
         </p:txBody>
@@ -861,10 +917,10 @@
         <p:txBody>
           <a:bodyPr xmlns:a="http://schemas.openxmlformats.org/drawingml/2006/main"/>
           <a:lstStyle xmlns:a="http://schemas.openxmlformats.org/drawingml/2006/main"/>
-          <a:p xmlns:a="http://schemas.openxmlformats.org/drawingml/2006/main">
+          <a:p>
             <a:r>
               <a:rPr lang="en-US"/>
-              <a:t>The final safety net checks concrete PDF quality. It does not claim to predict recruiter or ATS outcomes.</a:t>
+              <a:t>The app uses the GitHub Copilot SDK for tailored bilingual application documents.</a:t>
             </a:r>
           </a:p>
         </p:txBody>
@@ -916,10 +972,10 @@
         <p:txBody>
           <a:bodyPr xmlns:a="http://schemas.openxmlformats.org/drawingml/2006/main"/>
           <a:lstStyle xmlns:a="http://schemas.openxmlformats.org/drawingml/2006/main"/>
-          <a:p xmlns:a="http://schemas.openxmlformats.org/drawingml/2006/main">
+          <a:p>
             <a:r>
               <a:rPr lang="en-US"/>
-              <a:t>Close with the workflow: paste, review the facts, and generate with confidence.</a:t>
+              <a:t>Preflight catches issues before an application is marked sendable.</a:t>
             </a:r>
           </a:p>
         </p:txBody>
@@ -1227,9 +1283,20 @@
   <p:cSld>
     <p:bg>
       <p:bgPr>
-        <a:solidFill xmlns:a="http://schemas.openxmlformats.org/drawingml/2006/main">
-          <a:srgbClr val="101B33"/>
-        </a:solidFill>
+        <a:gradFill>
+          <a:gsLst>
+            <a:gs pos="0">
+              <a:srgbClr val="152A4A"/>
+            </a:gs>
+            <a:gs pos="50000">
+              <a:srgbClr val="342B75"/>
+            </a:gs>
+            <a:gs pos="100000">
+              <a:srgbClr val="135E8A"/>
+            </a:gs>
+          </a:gsLst>
+          <a:lin ang="1500000" scaled="1"/>
+        </a:gradFill>
       </p:bgPr>
     </p:bg>
     <p:spTree>
@@ -1377,14 +1444,25 @@
 </p:sld>
 </file>
 
-<file path=ppt/slides/slide2.xml><?xml version="1.0" encoding="utf-8"?>
+<file path=ppt/slides/slide10.xml><?xml version="1.0" encoding="utf-8"?>
 <p:sld xmlns:a="http://schemas.openxmlformats.org/drawingml/2006/main" xmlns:p="http://schemas.openxmlformats.org/presentationml/2006/main">
   <p:cSld>
     <p:bg>
       <p:bgPr>
-        <a:solidFill xmlns:a="http://schemas.openxmlformats.org/drawingml/2006/main">
-          <a:srgbClr val="162746"/>
-        </a:solidFill>
+        <a:gradFill>
+          <a:gsLst>
+            <a:gs pos="0">
+              <a:srgbClr val="152A4A"/>
+            </a:gs>
+            <a:gs pos="50000">
+              <a:srgbClr val="342B75"/>
+            </a:gs>
+            <a:gs pos="100000">
+              <a:srgbClr val="135E8A"/>
+            </a:gs>
+          </a:gsLst>
+          <a:lin ang="1500000" scaled="1"/>
+        </a:gradFill>
       </p:bgPr>
     </p:bg>
     <p:spTree>
@@ -1396,7 +1474,7 @@
       <p:grpSpPr/>
       <p:sp>
         <p:nvSpPr>
-          <p:cNvPr id="2" name="Title"/>
+          <p:cNvPr id="100018" name="Title"/>
           <p:cNvSpPr/>
           <p:nvPr>
             <p:ph type="title"/>
@@ -1418,14 +1496,14 @@
                   <a:srgbClr val="FFFFFF"/>
                 </a:solidFill>
               </a:rPr>
-              <a:t>The problem</a:t>
-            </a:r>
-          </a:p>
-        </p:txBody>
-      </p:sp>
-      <p:sp>
-        <p:nvSpPr>
-          <p:cNvPr id="3" name="Content"/>
+              <a:t>Jobseeker v3</a:t>
+            </a:r>
+          </a:p>
+        </p:txBody>
+      </p:sp>
+      <p:sp>
+        <p:nvSpPr>
+          <p:cNvPr id="100019" name="Content"/>
           <p:cNvSpPr txBox="1"/>
           <p:nvPr>
             <p:ph type="body" idx="1"/>
@@ -1440,47 +1518,17 @@
         <p:txBody>
           <a:bodyPr xmlns:a="http://schemas.openxmlformats.org/drawingml/2006/main"/>
           <a:lstStyle xmlns:a="http://schemas.openxmlformats.org/drawingml/2006/main"/>
-          <a:p xmlns:a="http://schemas.openxmlformats.org/drawingml/2006/main">
-            <a:r>
-              <a:rPr lang="en-US" sz="1800">
-                <a:solidFill>
-                  <a:srgbClr val="D9E7FF"/>
-                </a:solidFill>
-              </a:rPr>
-              <a:t>Job applications are repetitive</a:t>
-            </a:r>
-          </a:p>
-          <a:p xmlns:a="http://schemas.openxmlformats.org/drawingml/2006/main">
-            <a:r>
-              <a:rPr lang="en-US" sz="1800">
-                <a:solidFill>
-                  <a:srgbClr val="D9E7FF"/>
-                </a:solidFill>
-              </a:rPr>
-              <a:t>• Requirements are easy to miss</a:t>
-            </a:r>
-          </a:p>
-          <a:p xmlns:a="http://schemas.openxmlformats.org/drawingml/2006/main">
-            <a:r>
-              <a:rPr lang="en-US" sz="1800">
-                <a:solidFill>
-                  <a:srgbClr val="D9E7FF"/>
-                </a:solidFill>
-              </a:rPr>
-              <a:t>• AI can invent confidence</a:t>
-            </a:r>
-          </a:p>
-          <a:p xmlns:a="http://schemas.openxmlformats.org/drawingml/2006/main">
-            <a:r>
-              <a:rPr lang="en-US" sz="1800">
-                <a:solidFill>
-                  <a:srgbClr val="D9E7FF"/>
-                </a:solidFill>
-              </a:rPr>
-              <a:t>• PDFs can look fine but fail in practice</a:t>
-            </a:r>
-          </a:p>
-          <a:p xmlns:a="http://schemas.openxmlformats.org/drawingml/2006/main">
+          <a:p>
+            <a:r>
+              <a:rPr lang="en-US" sz="1800">
+                <a:solidFill>
+                  <a:srgbClr val="D9E7FF"/>
+                </a:solidFill>
+              </a:rPr>
+              <a:t>From listing to confidence</a:t>
+            </a:r>
+          </a:p>
+          <a:p>
             <a:r>
               <a:rPr lang="en-US" sz="1800">
                 <a:solidFill>
@@ -1490,21 +1538,41 @@
               <a:t/>
             </a:r>
           </a:p>
-          <a:p xmlns:a="http://schemas.openxmlformats.org/drawingml/2006/main">
-            <a:r>
-              <a:rPr lang="en-US" sz="1800">
-                <a:solidFill>
-                  <a:srgbClr val="D9E7FF"/>
-                </a:solidFill>
-              </a:rPr>
-              <a:t>Jobseeker v3 makes each step visible and reviewable.</a:t>
-            </a:r>
-          </a:p>
-        </p:txBody>
-      </p:sp>
-      <p:sp>
-        <p:nvSpPr>
-          <p:cNvPr id="100002" name="AccentBar2"/>
+          <a:p>
+            <a:r>
+              <a:rPr lang="en-US" sz="1800">
+                <a:solidFill>
+                  <a:srgbClr val="D9E7FF"/>
+                </a:solidFill>
+              </a:rPr>
+              <a:t>Paste a listing. Review the facts.</a:t>
+            </a:r>
+          </a:p>
+          <a:p>
+            <a:r>
+              <a:rPr lang="en-US" sz="1800">
+                <a:solidFill>
+                  <a:srgbClr val="D9E7FF"/>
+                </a:solidFill>
+              </a:rPr>
+              <a:t>Make the evidence yours.</a:t>
+            </a:r>
+          </a:p>
+          <a:p>
+            <a:r>
+              <a:rPr lang="en-US" sz="1800">
+                <a:solidFill>
+                  <a:srgbClr val="D9E7FF"/>
+                </a:solidFill>
+              </a:rPr>
+              <a:t>Generate an application you are proud to send.</a:t>
+            </a:r>
+          </a:p>
+        </p:txBody>
+      </p:sp>
+      <p:sp>
+        <p:nvSpPr>
+          <p:cNvPr id="100020" name="AccentBar9"/>
           <p:cNvSpPr/>
           <p:nvPr/>
         </p:nvSpPr>
@@ -1531,7 +1599,7 @@
       </p:sp>
       <p:sp>
         <p:nvSpPr>
-          <p:cNvPr id="100003" name="Footer2"/>
+          <p:cNvPr id="100021" name="Footer9"/>
           <p:cNvSpPr txBox="1"/>
           <p:nvPr/>
         </p:nvSpPr>
@@ -1569,17 +1637,28 @@
       </p:sp>
     </p:spTree>
   </p:cSld>
+  <p:transition>
+    <p:fade/>
+  </p:transition>
 </p:sld>
 </file>
 
-<file path=ppt/slides/slide3.xml><?xml version="1.0" encoding="utf-8"?>
+<file path=ppt/slides/slide2.xml><?xml version="1.0" encoding="utf-8"?>
 <p:sld xmlns:a="http://schemas.openxmlformats.org/drawingml/2006/main" xmlns:p="http://schemas.openxmlformats.org/presentationml/2006/main">
   <p:cSld>
     <p:bg>
       <p:bgPr>
-        <a:solidFill xmlns:a="http://schemas.openxmlformats.org/drawingml/2006/main">
-          <a:srgbClr val="101B33"/>
-        </a:solidFill>
+        <a:gradFill>
+          <a:gsLst>
+            <a:gs pos="0">
+              <a:srgbClr val="18233D"/>
+            </a:gs>
+            <a:gs pos="100000">
+              <a:srgbClr val="3B275F"/>
+            </a:gs>
+          </a:gsLst>
+          <a:lin ang="1200000" scaled="1"/>
+        </a:gradFill>
       </p:bgPr>
     </p:bg>
     <p:spTree>
@@ -1613,7 +1692,7 @@
                   <a:srgbClr val="FFFFFF"/>
                 </a:solidFill>
               </a:rPr>
-              <a:t>1  Start with the listing</a:t>
+              <a:t>The problem</a:t>
             </a:r>
           </a:p>
         </p:txBody>
@@ -1642,17 +1721,37 @@
                   <a:srgbClr val="D9E7FF"/>
                 </a:solidFill>
               </a:rPr>
-              <a:t>Paste the full job description</a:t>
-            </a:r>
-          </a:p>
-          <a:p xmlns:a="http://schemas.openxmlformats.org/drawingml/2006/main">
-            <a:r>
-              <a:rPr lang="en-US" sz="1800">
-                <a:solidFill>
-                  <a:srgbClr val="D9E7FF"/>
-                </a:solidFill>
-              </a:rPr>
-              <a:t>or share a job URL</a:t>
+              <a:t>Job applications are repetitive</a:t>
+            </a:r>
+          </a:p>
+          <a:p xmlns:a="http://schemas.openxmlformats.org/drawingml/2006/main">
+            <a:r>
+              <a:rPr lang="en-US" sz="1800">
+                <a:solidFill>
+                  <a:srgbClr val="D9E7FF"/>
+                </a:solidFill>
+              </a:rPr>
+              <a:t>• Requirements are easy to miss</a:t>
+            </a:r>
+          </a:p>
+          <a:p xmlns:a="http://schemas.openxmlformats.org/drawingml/2006/main">
+            <a:r>
+              <a:rPr lang="en-US" sz="1800">
+                <a:solidFill>
+                  <a:srgbClr val="D9E7FF"/>
+                </a:solidFill>
+              </a:rPr>
+              <a:t>• AI can invent confidence</a:t>
+            </a:r>
+          </a:p>
+          <a:p xmlns:a="http://schemas.openxmlformats.org/drawingml/2006/main">
+            <a:r>
+              <a:rPr lang="en-US" sz="1800">
+                <a:solidFill>
+                  <a:srgbClr val="D9E7FF"/>
+                </a:solidFill>
+              </a:rPr>
+              <a:t>• PDFs can look fine but fail in practice</a:t>
             </a:r>
           </a:p>
           <a:p xmlns:a="http://schemas.openxmlformats.org/drawingml/2006/main">
@@ -1672,14 +1771,14 @@
                   <a:srgbClr val="D9E7FF"/>
                 </a:solidFill>
               </a:rPr>
-              <a:t>The app extracts the content, checks quality, and shows the exact text before analysis.</a:t>
-            </a:r>
-          </a:p>
-        </p:txBody>
-      </p:sp>
-      <p:sp>
-        <p:nvSpPr>
-          <p:cNvPr id="100004" name="AccentBar3"/>
+              <a:t>Jobseeker v3 makes each step visible and reviewable.</a:t>
+            </a:r>
+          </a:p>
+        </p:txBody>
+      </p:sp>
+      <p:sp>
+        <p:nvSpPr>
+          <p:cNvPr id="100002" name="AccentBar2"/>
           <p:cNvSpPr/>
           <p:nvPr/>
         </p:nvSpPr>
@@ -1706,7 +1805,7 @@
       </p:sp>
       <p:sp>
         <p:nvSpPr>
-          <p:cNvPr id="100005" name="Footer3"/>
+          <p:cNvPr id="100003" name="Footer2"/>
           <p:cNvSpPr txBox="1"/>
           <p:nvPr/>
         </p:nvSpPr>
@@ -1747,14 +1846,22 @@
 </p:sld>
 </file>
 
-<file path=ppt/slides/slide4.xml><?xml version="1.0" encoding="utf-8"?>
+<file path=ppt/slides/slide3.xml><?xml version="1.0" encoding="utf-8"?>
 <p:sld xmlns:a="http://schemas.openxmlformats.org/drawingml/2006/main" xmlns:p="http://schemas.openxmlformats.org/presentationml/2006/main">
   <p:cSld>
     <p:bg>
       <p:bgPr>
-        <a:solidFill xmlns:a="http://schemas.openxmlformats.org/drawingml/2006/main">
-          <a:srgbClr val="162746"/>
-        </a:solidFill>
+        <a:gradFill>
+          <a:gsLst>
+            <a:gs pos="0">
+              <a:srgbClr val="102C3A"/>
+            </a:gs>
+            <a:gs pos="100000">
+              <a:srgbClr val="174E58"/>
+            </a:gs>
+          </a:gsLst>
+          <a:lin ang="1500000" scaled="1"/>
+        </a:gradFill>
       </p:bgPr>
     </p:bg>
     <p:spTree>
@@ -1788,7 +1895,7 @@
                   <a:srgbClr val="FFFFFF"/>
                 </a:solidFill>
               </a:rPr>
-              <a:t>2  See the evidence</a:t>
+              <a:t>1  Start with the listing</a:t>
             </a:r>
           </a:p>
         </p:txBody>
@@ -1817,7 +1924,17 @@
                   <a:srgbClr val="D9E7FF"/>
                 </a:solidFill>
               </a:rPr>
-              <a:t>Every requirement gets a visible verdict</a:t>
+              <a:t>Paste the full job description</a:t>
+            </a:r>
+          </a:p>
+          <a:p xmlns:a="http://schemas.openxmlformats.org/drawingml/2006/main">
+            <a:r>
+              <a:rPr lang="en-US" sz="1800">
+                <a:solidFill>
+                  <a:srgbClr val="D9E7FF"/>
+                </a:solidFill>
+              </a:rPr>
+              <a:t>or share a job URL</a:t>
             </a:r>
           </a:p>
           <a:p xmlns:a="http://schemas.openxmlformats.org/drawingml/2006/main">
@@ -1837,54 +1954,14 @@
                   <a:srgbClr val="D9E7FF"/>
                 </a:solidFill>
               </a:rPr>
-              <a:t>YES  covered by your knowledge</a:t>
-            </a:r>
-          </a:p>
-          <a:p xmlns:a="http://schemas.openxmlformats.org/drawingml/2006/main">
-            <a:r>
-              <a:rPr lang="en-US" sz="1800">
-                <a:solidFill>
-                  <a:srgbClr val="D9E7FF"/>
-                </a:solidFill>
-              </a:rPr>
-              <a:t>PARTIAL  some evidence</a:t>
-            </a:r>
-          </a:p>
-          <a:p xmlns:a="http://schemas.openxmlformats.org/drawingml/2006/main">
-            <a:r>
-              <a:rPr lang="en-US" sz="1800">
-                <a:solidFill>
-                  <a:srgbClr val="D9E7FF"/>
-                </a:solidFill>
-              </a:rPr>
-              <a:t>NO  gap or missing proof</a:t>
-            </a:r>
-          </a:p>
-          <a:p xmlns:a="http://schemas.openxmlformats.org/drawingml/2006/main">
-            <a:r>
-              <a:rPr lang="en-US" sz="1800">
-                <a:solidFill>
-                  <a:srgbClr val="D9E7FF"/>
-                </a:solidFill>
-              </a:rPr>
-              <a:t/>
-            </a:r>
-          </a:p>
-          <a:p xmlns:a="http://schemas.openxmlformats.org/drawingml/2006/main">
-            <a:r>
-              <a:rPr lang="en-US" sz="1800">
-                <a:solidFill>
-                  <a:srgbClr val="D9E7FF"/>
-                </a:solidFill>
-              </a:rPr>
-              <a:t>Each result includes provenance, confidence, and an evidence quote.</a:t>
-            </a:r>
-          </a:p>
-        </p:txBody>
-      </p:sp>
-      <p:sp>
-        <p:nvSpPr>
-          <p:cNvPr id="100006" name="AccentBar4"/>
+              <a:t>The app extracts the content, checks quality, and shows the exact text before analysis.</a:t>
+            </a:r>
+          </a:p>
+        </p:txBody>
+      </p:sp>
+      <p:sp>
+        <p:nvSpPr>
+          <p:cNvPr id="100004" name="AccentBar3"/>
           <p:cNvSpPr/>
           <p:nvPr/>
         </p:nvSpPr>
@@ -1911,7 +1988,7 @@
       </p:sp>
       <p:sp>
         <p:nvSpPr>
-          <p:cNvPr id="100007" name="Footer4"/>
+          <p:cNvPr id="100005" name="Footer3"/>
           <p:cNvSpPr txBox="1"/>
           <p:nvPr/>
         </p:nvSpPr>
@@ -1952,14 +2029,22 @@
 </p:sld>
 </file>
 
-<file path=ppt/slides/slide5.xml><?xml version="1.0" encoding="utf-8"?>
+<file path=ppt/slides/slide4.xml><?xml version="1.0" encoding="utf-8"?>
 <p:sld xmlns:a="http://schemas.openxmlformats.org/drawingml/2006/main" xmlns:p="http://schemas.openxmlformats.org/presentationml/2006/main">
   <p:cSld>
     <p:bg>
       <p:bgPr>
-        <a:solidFill xmlns:a="http://schemas.openxmlformats.org/drawingml/2006/main">
-          <a:srgbClr val="101B33"/>
-        </a:solidFill>
+        <a:gradFill>
+          <a:gsLst>
+            <a:gs pos="0">
+              <a:srgbClr val="152A4A"/>
+            </a:gs>
+            <a:gs pos="100000">
+              <a:srgbClr val="243B75"/>
+            </a:gs>
+          </a:gsLst>
+          <a:lin ang="1500000" scaled="1"/>
+        </a:gradFill>
       </p:bgPr>
     </p:bg>
     <p:spTree>
@@ -1993,7 +2078,7 @@
                   <a:srgbClr val="FFFFFF"/>
                 </a:solidFill>
               </a:rPr>
-              <a:t>3  Stay in control</a:t>
+              <a:t>2  See the evidence</a:t>
             </a:r>
           </a:p>
         </p:txBody>
@@ -2022,7 +2107,7 @@
                   <a:srgbClr val="D9E7FF"/>
                 </a:solidFill>
               </a:rPr>
-              <a:t>Set requirements independently</a:t>
+              <a:t>Every requirement gets a visible verdict</a:t>
             </a:r>
           </a:p>
           <a:p xmlns:a="http://schemas.openxmlformats.org/drawingml/2006/main">
@@ -2042,27 +2127,27 @@
                   <a:srgbClr val="D9E7FF"/>
                 </a:solidFill>
               </a:rPr>
-              <a:t>Terraform = Yes</a:t>
-            </a:r>
-          </a:p>
-          <a:p xmlns:a="http://schemas.openxmlformats.org/drawingml/2006/main">
-            <a:r>
-              <a:rPr lang="en-US" sz="1800">
-                <a:solidFill>
-                  <a:srgbClr val="D9E7FF"/>
-                </a:solidFill>
-              </a:rPr>
-              <a:t>Kubernetes = No</a:t>
-            </a:r>
-          </a:p>
-          <a:p xmlns:a="http://schemas.openxmlformats.org/drawingml/2006/main">
-            <a:r>
-              <a:rPr lang="en-US" sz="1800">
-                <a:solidFill>
-                  <a:srgbClr val="D9E7FF"/>
-                </a:solidFill>
-              </a:rPr>
-              <a:t>Stakeholder = Yes</a:t>
+              <a:t>YES  covered by your knowledge</a:t>
+            </a:r>
+          </a:p>
+          <a:p xmlns:a="http://schemas.openxmlformats.org/drawingml/2006/main">
+            <a:r>
+              <a:rPr lang="en-US" sz="1800">
+                <a:solidFill>
+                  <a:srgbClr val="D9E7FF"/>
+                </a:solidFill>
+              </a:rPr>
+              <a:t>PARTIAL  some evidence</a:t>
+            </a:r>
+          </a:p>
+          <a:p xmlns:a="http://schemas.openxmlformats.org/drawingml/2006/main">
+            <a:r>
+              <a:rPr lang="en-US" sz="1800">
+                <a:solidFill>
+                  <a:srgbClr val="D9E7FF"/>
+                </a:solidFill>
+              </a:rPr>
+              <a:t>NO  gap or missing proof</a:t>
             </a:r>
           </a:p>
           <a:p xmlns:a="http://schemas.openxmlformats.org/drawingml/2006/main">
@@ -2082,14 +2167,14 @@
                   <a:srgbClr val="D9E7FF"/>
                 </a:solidFill>
               </a:rPr>
-              <a:t>Use the verdict controls to correct the analysis before continuing.</a:t>
-            </a:r>
-          </a:p>
-        </p:txBody>
-      </p:sp>
-      <p:sp>
-        <p:nvSpPr>
-          <p:cNvPr id="100008" name="AccentBar5"/>
+              <a:t>Each result includes provenance, confidence, and an evidence quote.</a:t>
+            </a:r>
+          </a:p>
+        </p:txBody>
+      </p:sp>
+      <p:sp>
+        <p:nvSpPr>
+          <p:cNvPr id="100006" name="AccentBar4"/>
           <p:cNvSpPr/>
           <p:nvPr/>
         </p:nvSpPr>
@@ -2116,7 +2201,7 @@
       </p:sp>
       <p:sp>
         <p:nvSpPr>
-          <p:cNvPr id="100009" name="Footer5"/>
+          <p:cNvPr id="100007" name="Footer4"/>
           <p:cNvSpPr txBox="1"/>
           <p:nvPr/>
         </p:nvSpPr>
@@ -2157,14 +2242,22 @@
 </p:sld>
 </file>
 
-<file path=ppt/slides/slide6.xml><?xml version="1.0" encoding="utf-8"?>
+<file path=ppt/slides/slide5.xml><?xml version="1.0" encoding="utf-8"?>
 <p:sld xmlns:a="http://schemas.openxmlformats.org/drawingml/2006/main" xmlns:p="http://schemas.openxmlformats.org/presentationml/2006/main">
   <p:cSld>
     <p:bg>
       <p:bgPr>
-        <a:solidFill xmlns:a="http://schemas.openxmlformats.org/drawingml/2006/main">
-          <a:srgbClr val="162746"/>
-        </a:solidFill>
+        <a:gradFill>
+          <a:gsLst>
+            <a:gs pos="0">
+              <a:srgbClr val="241D4A"/>
+            </a:gs>
+            <a:gs pos="100000">
+              <a:srgbClr val="4B255F"/>
+            </a:gs>
+          </a:gsLst>
+          <a:lin ang="1500000" scaled="1"/>
+        </a:gradFill>
       </p:bgPr>
     </p:bg>
     <p:spTree>
@@ -2198,7 +2291,7 @@
                   <a:srgbClr val="FFFFFF"/>
                 </a:solidFill>
               </a:rPr>
-              <a:t>4  Protect your knowledge</a:t>
+              <a:t>3  Stay in control</a:t>
             </a:r>
           </a:p>
         </p:txBody>
@@ -2227,7 +2320,7 @@
                   <a:srgbClr val="D9E7FF"/>
                 </a:solidFill>
               </a:rPr>
-              <a:t>New evidence is proposed — never silently saved</a:t>
+              <a:t>Set requirements independently</a:t>
             </a:r>
           </a:p>
           <a:p xmlns:a="http://schemas.openxmlformats.org/drawingml/2006/main">
@@ -2247,34 +2340,54 @@
                   <a:srgbClr val="D9E7FF"/>
                 </a:solidFill>
               </a:rPr>
-              <a:t>Review each item</a:t>
-            </a:r>
-          </a:p>
-          <a:p xmlns:a="http://schemas.openxmlformats.org/drawingml/2006/main">
-            <a:r>
-              <a:rPr lang="en-US" sz="1800">
-                <a:solidFill>
-                  <a:srgbClr val="D9E7FF"/>
-                </a:solidFill>
-              </a:rPr>
-              <a:t>Uncheck anything you do not want to keep</a:t>
-            </a:r>
-          </a:p>
-          <a:p xmlns:a="http://schemas.openxmlformats.org/drawingml/2006/main">
-            <a:r>
-              <a:rPr lang="en-US" sz="1800">
-                <a:solidFill>
-                  <a:srgbClr val="D9E7FF"/>
-                </a:solidFill>
-              </a:rPr>
-              <a:t>Approve only what belongs in your knowledge folder</a:t>
-            </a:r>
-          </a:p>
-        </p:txBody>
-      </p:sp>
-      <p:sp>
-        <p:nvSpPr>
-          <p:cNvPr id="100010" name="AccentBar6"/>
+              <a:t>Terraform = Yes</a:t>
+            </a:r>
+          </a:p>
+          <a:p xmlns:a="http://schemas.openxmlformats.org/drawingml/2006/main">
+            <a:r>
+              <a:rPr lang="en-US" sz="1800">
+                <a:solidFill>
+                  <a:srgbClr val="D9E7FF"/>
+                </a:solidFill>
+              </a:rPr>
+              <a:t>Kubernetes = No</a:t>
+            </a:r>
+          </a:p>
+          <a:p xmlns:a="http://schemas.openxmlformats.org/drawingml/2006/main">
+            <a:r>
+              <a:rPr lang="en-US" sz="1800">
+                <a:solidFill>
+                  <a:srgbClr val="D9E7FF"/>
+                </a:solidFill>
+              </a:rPr>
+              <a:t>Stakeholder = Yes</a:t>
+            </a:r>
+          </a:p>
+          <a:p xmlns:a="http://schemas.openxmlformats.org/drawingml/2006/main">
+            <a:r>
+              <a:rPr lang="en-US" sz="1800">
+                <a:solidFill>
+                  <a:srgbClr val="D9E7FF"/>
+                </a:solidFill>
+              </a:rPr>
+              <a:t/>
+            </a:r>
+          </a:p>
+          <a:p xmlns:a="http://schemas.openxmlformats.org/drawingml/2006/main">
+            <a:r>
+              <a:rPr lang="en-US" sz="1800">
+                <a:solidFill>
+                  <a:srgbClr val="D9E7FF"/>
+                </a:solidFill>
+              </a:rPr>
+              <a:t>Use the verdict controls to correct the analysis before continuing.</a:t>
+            </a:r>
+          </a:p>
+        </p:txBody>
+      </p:sp>
+      <p:sp>
+        <p:nvSpPr>
+          <p:cNvPr id="100008" name="AccentBar5"/>
           <p:cNvSpPr/>
           <p:nvPr/>
         </p:nvSpPr>
@@ -2301,7 +2414,7 @@
       </p:sp>
       <p:sp>
         <p:nvSpPr>
-          <p:cNvPr id="100011" name="Footer6"/>
+          <p:cNvPr id="100009" name="Footer5"/>
           <p:cNvSpPr txBox="1"/>
           <p:nvPr/>
         </p:nvSpPr>
@@ -2342,14 +2455,22 @@
 </p:sld>
 </file>
 
-<file path=ppt/slides/slide7.xml><?xml version="1.0" encoding="utf-8"?>
+<file path=ppt/slides/slide6.xml><?xml version="1.0" encoding="utf-8"?>
 <p:sld xmlns:a="http://schemas.openxmlformats.org/drawingml/2006/main" xmlns:p="http://schemas.openxmlformats.org/presentationml/2006/main">
   <p:cSld>
     <p:bg>
       <p:bgPr>
-        <a:solidFill xmlns:a="http://schemas.openxmlformats.org/drawingml/2006/main">
-          <a:srgbClr val="101B33"/>
-        </a:solidFill>
+        <a:gradFill>
+          <a:gsLst>
+            <a:gs pos="0">
+              <a:srgbClr val="123B42"/>
+            </a:gs>
+            <a:gs pos="100000">
+              <a:srgbClr val="1D5C55"/>
+            </a:gs>
+          </a:gsLst>
+          <a:lin ang="1500000" scaled="1"/>
+        </a:gradFill>
       </p:bgPr>
     </p:bg>
     <p:spTree>
@@ -2383,7 +2504,7 @@
                   <a:srgbClr val="FFFFFF"/>
                 </a:solidFill>
               </a:rPr>
-              <a:t>5  Generate with GitHub Copilot</a:t>
+              <a:t>4  Protect your knowledge</a:t>
             </a:r>
           </a:p>
         </p:txBody>
@@ -2412,7 +2533,7 @@
                   <a:srgbClr val="D9E7FF"/>
                 </a:solidFill>
               </a:rPr>
-              <a:t>The app uses the GitHub Copilot SDK</a:t>
+              <a:t>New evidence is proposed — never silently saved</a:t>
             </a:r>
           </a:p>
           <a:p xmlns:a="http://schemas.openxmlformats.org/drawingml/2006/main">
@@ -2432,55 +2553,34 @@
                   <a:srgbClr val="D9E7FF"/>
                 </a:solidFill>
               </a:rPr>
-              <a:t>• Copilot model selection</a:t>
-            </a:r>
-          </a:p>
-          <a:p xmlns:a="http://schemas.openxmlformats.org/drawingml/2006/main">
-            <a:r>
-              <a:rPr lang="en-US" sz="1800">
-                <a:solidFill>
-                  <a:srgbClr val="D9E7FF"/>
-                </a:solidFill>
-              </a:rPr>
-              <a:t>• Local-first application state</a:t>
-            </a:r>
-          </a:p>
-          <a:p xmlns:a="http://schemas.openxmlformats.org/drawingml/2006/main">
-            <a:r>
-              <a:rPr lang="en-US" sz="1800">
-                <a:solidFill>
-                  <a:srgbClr val="D9E7FF"/>
-                </a:solidFill>
-              </a:rPr>
-              <a:t>• Tailored CV + cover letter content</a:t>
-            </a:r>
-          </a:p>
-          <a:p xmlns:a="http://schemas.openxmlformats.org/drawingml/2006/main">
-            <a:r>
-              <a:rPr lang="en-US" sz="1800">
-                <a:solidFill>
-                  <a:srgbClr val="D9E7FF"/>
-                </a:solidFill>
-              </a:rPr>
-              <a:t>• Danish and English output</a:t>
-            </a:r>
-          </a:p>
-          <a:p xmlns:a="http://schemas.openxmlformats.org/drawingml/2006/main">
-            <a:r>
-              <a:rPr lang="en-US" sz="1800">
-                <a:solidFill>
-                  <a:srgbClr val="D9E7FF"/>
-                </a:solidFill>
-              </a:rPr>
-              <a:t/>
-            </a:r>
-          </a:p>
-          <a:p xmlns:a="http://schemas.openxmlformats.org/drawingml/2006/main"/>
-        </p:txBody>
-      </p:sp>
-      <p:sp>
-        <p:nvSpPr>
-          <p:cNvPr id="100012" name="AccentBar7"/>
+              <a:t>Review each item</a:t>
+            </a:r>
+          </a:p>
+          <a:p xmlns:a="http://schemas.openxmlformats.org/drawingml/2006/main">
+            <a:r>
+              <a:rPr lang="en-US" sz="1800">
+                <a:solidFill>
+                  <a:srgbClr val="D9E7FF"/>
+                </a:solidFill>
+              </a:rPr>
+              <a:t>Uncheck anything you do not want to keep</a:t>
+            </a:r>
+          </a:p>
+          <a:p xmlns:a="http://schemas.openxmlformats.org/drawingml/2006/main">
+            <a:r>
+              <a:rPr lang="en-US" sz="1800">
+                <a:solidFill>
+                  <a:srgbClr val="D9E7FF"/>
+                </a:solidFill>
+              </a:rPr>
+              <a:t>Approve only what belongs in your knowledge folder</a:t>
+            </a:r>
+          </a:p>
+        </p:txBody>
+      </p:sp>
+      <p:sp>
+        <p:nvSpPr>
+          <p:cNvPr id="100010" name="AccentBar6"/>
           <p:cNvSpPr/>
           <p:nvPr/>
         </p:nvSpPr>
@@ -2507,7 +2607,7 @@
       </p:sp>
       <p:sp>
         <p:nvSpPr>
-          <p:cNvPr id="100013" name="Footer7"/>
+          <p:cNvPr id="100011" name="Footer6"/>
           <p:cNvSpPr txBox="1"/>
           <p:nvPr/>
         </p:nvSpPr>
@@ -2548,14 +2648,22 @@
 </p:sld>
 </file>
 
-<file path=ppt/slides/slide8.xml><?xml version="1.0" encoding="utf-8"?>
+<file path=ppt/slides/slide7.xml><?xml version="1.0" encoding="utf-8"?>
 <p:sld xmlns:a="http://schemas.openxmlformats.org/drawingml/2006/main" xmlns:p="http://schemas.openxmlformats.org/presentationml/2006/main">
   <p:cSld>
     <p:bg>
       <p:bgPr>
-        <a:solidFill xmlns:a="http://schemas.openxmlformats.org/drawingml/2006/main">
-          <a:srgbClr val="162746"/>
-        </a:solidFill>
+        <a:gradFill>
+          <a:gsLst>
+            <a:gs pos="0">
+              <a:srgbClr val="18233D"/>
+            </a:gs>
+            <a:gs pos="100000">
+              <a:srgbClr val="3B275F"/>
+            </a:gs>
+          </a:gsLst>
+          <a:lin ang="1500000" scaled="1"/>
+        </a:gradFill>
       </p:bgPr>
     </p:bg>
     <p:spTree>
@@ -2589,7 +2697,7 @@
                   <a:srgbClr val="FFFFFF"/>
                 </a:solidFill>
               </a:rPr>
-              <a:t>6  Preflight before send</a:t>
+              <a:t>5  Make the workflow yours</a:t>
             </a:r>
           </a:p>
         </p:txBody>
@@ -2611,17 +2719,17 @@
         <p:txBody>
           <a:bodyPr xmlns:a="http://schemas.openxmlformats.org/drawingml/2006/main"/>
           <a:lstStyle xmlns:a="http://schemas.openxmlformats.org/drawingml/2006/main"/>
-          <a:p xmlns:a="http://schemas.openxmlformats.org/drawingml/2006/main">
-            <a:r>
-              <a:rPr lang="en-US" sz="1800">
-                <a:solidFill>
-                  <a:srgbClr val="D9E7FF"/>
-                </a:solidFill>
-              </a:rPr>
-              <a:t>Every PDF is checked deterministically</a:t>
-            </a:r>
-          </a:p>
-          <a:p xmlns:a="http://schemas.openxmlformats.org/drawingml/2006/main">
+          <a:p>
+            <a:r>
+              <a:rPr lang="en-US" sz="1800">
+                <a:solidFill>
+                  <a:srgbClr val="D9E7FF"/>
+                </a:solidFill>
+              </a:rPr>
+              <a:t>Edit six user-facing prompts from the Knowledge sidebar</a:t>
+            </a:r>
+          </a:p>
+          <a:p>
             <a:r>
               <a:rPr lang="en-US" sz="1800">
                 <a:solidFill>
@@ -2631,37 +2739,47 @@
               <a:t/>
             </a:r>
           </a:p>
-          <a:p xmlns:a="http://schemas.openxmlformats.org/drawingml/2006/main">
-            <a:r>
-              <a:rPr lang="en-US" sz="1800">
-                <a:solidFill>
-                  <a:srgbClr val="D9E7FF"/>
-                </a:solidFill>
-              </a:rPr>
-              <a:t>Text extractable  •  language correct</a:t>
-            </a:r>
-          </a:p>
-          <a:p xmlns:a="http://schemas.openxmlformats.org/drawingml/2006/main">
-            <a:r>
-              <a:rPr lang="en-US" sz="1800">
-                <a:solidFill>
-                  <a:srgbClr val="D9E7FF"/>
-                </a:solidFill>
-              </a:rPr>
-              <a:t>Sections present  •  no blank pages</a:t>
-            </a:r>
-          </a:p>
-          <a:p xmlns:a="http://schemas.openxmlformats.org/drawingml/2006/main">
-            <a:r>
-              <a:rPr lang="en-US" sz="1800">
-                <a:solidFill>
-                  <a:srgbClr val="D9E7FF"/>
-                </a:solidFill>
-              </a:rPr>
-              <a:t>No placeholders  •  correct document type</a:t>
-            </a:r>
-          </a:p>
-          <a:p xmlns:a="http://schemas.openxmlformats.org/drawingml/2006/main">
+          <a:p>
+            <a:r>
+              <a:rPr lang="en-US" sz="1800">
+                <a:solidFill>
+                  <a:srgbClr val="D9E7FF"/>
+                </a:solidFill>
+              </a:rPr>
+              <a:t>• Tune listing analysis and requirement matching</a:t>
+            </a:r>
+          </a:p>
+          <a:p>
+            <a:r>
+              <a:rPr lang="en-US" sz="1800">
+                <a:solidFill>
+                  <a:srgbClr val="D9E7FF"/>
+                </a:solidFill>
+              </a:rPr>
+              <a:t>• Shape interview questions and answer interpretation</a:t>
+            </a:r>
+          </a:p>
+          <a:p>
+            <a:r>
+              <a:rPr lang="en-US" sz="1800">
+                <a:solidFill>
+                  <a:srgbClr val="D9E7FF"/>
+                </a:solidFill>
+              </a:rPr>
+              <a:t>• Refine document generation and idle-chat guidance</a:t>
+            </a:r>
+          </a:p>
+          <a:p>
+            <a:r>
+              <a:rPr lang="en-US" sz="1800">
+                <a:solidFill>
+                  <a:srgbClr val="D9E7FF"/>
+                </a:solidFill>
+              </a:rPr>
+              <a:t>• Inspect prompts and responses in the LLM thinking trace</a:t>
+            </a:r>
+          </a:p>
+          <a:p>
             <a:r>
               <a:rPr lang="en-US" sz="1800">
                 <a:solidFill>
@@ -2671,31 +2789,21 @@
               <a:t/>
             </a:r>
           </a:p>
-          <a:p xmlns:a="http://schemas.openxmlformats.org/drawingml/2006/main">
-            <a:r>
-              <a:rPr lang="en-US" sz="1800">
-                <a:solidFill>
-                  <a:srgbClr val="D9E7FF"/>
-                </a:solidFill>
-              </a:rPr>
-              <a:t>Passed = sendable</a:t>
-            </a:r>
-          </a:p>
-          <a:p xmlns:a="http://schemas.openxmlformats.org/drawingml/2006/main">
-            <a:r>
-              <a:rPr lang="en-US" sz="1800">
-                <a:solidFill>
-                  <a:srgbClr val="D9E7FF"/>
-                </a:solidFill>
-              </a:rPr>
-              <a:t>Issues = saved as a draft for review</a:t>
-            </a:r>
-          </a:p>
-        </p:txBody>
-      </p:sp>
-      <p:sp>
-        <p:nvSpPr>
-          <p:cNvPr id="100014" name="AccentBar8"/>
+          <a:p>
+            <a:r>
+              <a:rPr lang="en-US" sz="1800">
+                <a:solidFill>
+                  <a:srgbClr val="D9E7FF"/>
+                </a:solidFill>
+              </a:rPr>
+              <a:t>Your workflow. Your evidence. Your control.</a:t>
+            </a:r>
+          </a:p>
+        </p:txBody>
+      </p:sp>
+      <p:sp>
+        <p:nvSpPr>
+          <p:cNvPr id="100012" name="AccentBar7"/>
           <p:cNvSpPr/>
           <p:nvPr/>
         </p:nvSpPr>
@@ -2722,7 +2830,7 @@
       </p:sp>
       <p:sp>
         <p:nvSpPr>
-          <p:cNvPr id="100015" name="Footer8"/>
+          <p:cNvPr id="100013" name="Footer7"/>
           <p:cNvSpPr txBox="1"/>
           <p:nvPr/>
         </p:nvSpPr>
@@ -2760,17 +2868,28 @@
       </p:sp>
     </p:spTree>
   </p:cSld>
+  <p:transition>
+    <p:fade/>
+  </p:transition>
 </p:sld>
 </file>
 
-<file path=ppt/slides/slide9.xml><?xml version="1.0" encoding="utf-8"?>
+<file path=ppt/slides/slide8.xml><?xml version="1.0" encoding="utf-8"?>
 <p:sld xmlns:a="http://schemas.openxmlformats.org/drawingml/2006/main" xmlns:p="http://schemas.openxmlformats.org/presentationml/2006/main">
   <p:cSld>
     <p:bg>
       <p:bgPr>
-        <a:solidFill xmlns:a="http://schemas.openxmlformats.org/drawingml/2006/main">
-          <a:srgbClr val="101B33"/>
-        </a:solidFill>
+        <a:gradFill>
+          <a:gsLst>
+            <a:gs pos="0">
+              <a:srgbClr val="102C3A"/>
+            </a:gs>
+            <a:gs pos="100000">
+              <a:srgbClr val="174E58"/>
+            </a:gs>
+          </a:gsLst>
+          <a:lin ang="1500000" scaled="1"/>
+        </a:gradFill>
       </p:bgPr>
     </p:bg>
     <p:spTree>
@@ -2804,7 +2923,7 @@
                   <a:srgbClr val="FFFFFF"/>
                 </a:solidFill>
               </a:rPr>
-              <a:t>Jobseeker v3</a:t>
+              <a:t>6  Generate in two languages</a:t>
             </a:r>
           </a:p>
         </p:txBody>
@@ -2826,27 +2945,17 @@
         <p:txBody>
           <a:bodyPr xmlns:a="http://schemas.openxmlformats.org/drawingml/2006/main"/>
           <a:lstStyle xmlns:a="http://schemas.openxmlformats.org/drawingml/2006/main"/>
-          <a:p xmlns:a="http://schemas.openxmlformats.org/drawingml/2006/main">
-            <a:r>
-              <a:rPr lang="en-US" sz="1800">
-                <a:solidFill>
-                  <a:srgbClr val="D9E7FF"/>
-                </a:solidFill>
-              </a:rPr>
-              <a:t>A faster application workflow</a:t>
-            </a:r>
-          </a:p>
-          <a:p xmlns:a="http://schemas.openxmlformats.org/drawingml/2006/main">
-            <a:r>
-              <a:rPr lang="en-US" sz="1800">
-                <a:solidFill>
-                  <a:srgbClr val="D9E7FF"/>
-                </a:solidFill>
-              </a:rPr>
-              <a:t>without giving up evidence or control</a:t>
-            </a:r>
-          </a:p>
-          <a:p xmlns:a="http://schemas.openxmlformats.org/drawingml/2006/main">
+          <a:p>
+            <a:r>
+              <a:rPr lang="en-US" sz="1800">
+                <a:solidFill>
+                  <a:srgbClr val="D9E7FF"/>
+                </a:solidFill>
+              </a:rPr>
+              <a:t>Generate four tailored documents from one reviewed job</a:t>
+            </a:r>
+          </a:p>
+          <a:p>
             <a:r>
               <a:rPr lang="en-US" sz="1800">
                 <a:solidFill>
@@ -2856,31 +2965,71 @@
               <a:t/>
             </a:r>
           </a:p>
-          <a:p xmlns:a="http://schemas.openxmlformats.org/drawingml/2006/main">
-            <a:r>
-              <a:rPr lang="en-US" sz="1800">
-                <a:solidFill>
-                  <a:srgbClr val="D9E7FF"/>
-                </a:solidFill>
-              </a:rPr>
-              <a:t>Paste a listing. Review the facts.</a:t>
-            </a:r>
-          </a:p>
-          <a:p xmlns:a="http://schemas.openxmlformats.org/drawingml/2006/main">
-            <a:r>
-              <a:rPr lang="en-US" sz="1800">
-                <a:solidFill>
-                  <a:srgbClr val="D9E7FF"/>
-                </a:solidFill>
-              </a:rPr>
-              <a:t>Generate with confidence.</a:t>
-            </a:r>
-          </a:p>
-        </p:txBody>
-      </p:sp>
-      <p:sp>
-        <p:nvSpPr>
-          <p:cNvPr id="100016" name="AccentBar9"/>
+          <a:p>
+            <a:r>
+              <a:rPr lang="en-US" sz="1800">
+                <a:solidFill>
+                  <a:srgbClr val="D9E7FF"/>
+                </a:solidFill>
+              </a:rPr>
+              <a:t>• CV — English</a:t>
+            </a:r>
+          </a:p>
+          <a:p>
+            <a:r>
+              <a:rPr lang="en-US" sz="1800">
+                <a:solidFill>
+                  <a:srgbClr val="D9E7FF"/>
+                </a:solidFill>
+              </a:rPr>
+              <a:t>• CV — Dansk</a:t>
+            </a:r>
+          </a:p>
+          <a:p>
+            <a:r>
+              <a:rPr lang="en-US" sz="1800">
+                <a:solidFill>
+                  <a:srgbClr val="D9E7FF"/>
+                </a:solidFill>
+              </a:rPr>
+              <a:t>• Cover Letter — English</a:t>
+            </a:r>
+          </a:p>
+          <a:p>
+            <a:r>
+              <a:rPr lang="en-US" sz="1800">
+                <a:solidFill>
+                  <a:srgbClr val="D9E7FF"/>
+                </a:solidFill>
+              </a:rPr>
+              <a:t>• Ansøgning — Dansk</a:t>
+            </a:r>
+          </a:p>
+          <a:p>
+            <a:r>
+              <a:rPr lang="en-US" sz="1800">
+                <a:solidFill>
+                  <a:srgbClr val="D9E7FF"/>
+                </a:solidFill>
+              </a:rPr>
+              <a:t/>
+            </a:r>
+          </a:p>
+          <a:p>
+            <a:r>
+              <a:rPr lang="en-US" sz="1800">
+                <a:solidFill>
+                  <a:srgbClr val="D9E7FF"/>
+                </a:solidFill>
+              </a:rPr>
+              <a:t>Powered by the GitHub Copilot SDK, grounded in your approved knowledge, and kept local on your machine.</a:t>
+            </a:r>
+          </a:p>
+        </p:txBody>
+      </p:sp>
+      <p:sp>
+        <p:nvSpPr>
+          <p:cNvPr id="100014" name="AccentBar8"/>
           <p:cNvSpPr/>
           <p:nvPr/>
         </p:nvSpPr>
@@ -2907,7 +3056,7 @@
       </p:sp>
       <p:sp>
         <p:nvSpPr>
-          <p:cNvPr id="100017" name="Footer9"/>
+          <p:cNvPr id="100015" name="Footer8"/>
           <p:cNvSpPr txBox="1"/>
           <p:nvPr/>
         </p:nvSpPr>
@@ -2945,6 +3094,258 @@
       </p:sp>
     </p:spTree>
   </p:cSld>
+  <p:transition>
+    <p:fade/>
+  </p:transition>
+</p:sld>
+</file>
+
+<file path=ppt/slides/slide9.xml><?xml version="1.0" encoding="utf-8"?>
+<p:sld xmlns:a="http://schemas.openxmlformats.org/drawingml/2006/main" xmlns:p="http://schemas.openxmlformats.org/presentationml/2006/main">
+  <p:cSld>
+    <p:bg>
+      <p:bgPr>
+        <a:gradFill>
+          <a:gsLst>
+            <a:gs pos="0">
+              <a:srgbClr val="152A4A"/>
+            </a:gs>
+            <a:gs pos="50000">
+              <a:srgbClr val="342B75"/>
+            </a:gs>
+            <a:gs pos="100000">
+              <a:srgbClr val="135E8A"/>
+            </a:gs>
+          </a:gsLst>
+          <a:lin ang="1500000" scaled="1"/>
+        </a:gradFill>
+      </p:bgPr>
+    </p:bg>
+    <p:spTree>
+      <p:nvGrpSpPr>
+        <p:cNvPr id="1" name=""/>
+        <p:cNvGrpSpPr/>
+        <p:nvPr/>
+      </p:nvGrpSpPr>
+      <p:grpSpPr/>
+      <p:sp>
+        <p:nvSpPr>
+          <p:cNvPr id="2" name="Title"/>
+          <p:cNvSpPr/>
+          <p:nvPr>
+            <p:ph type="title"/>
+          </p:nvPr>
+        </p:nvSpPr>
+        <p:spPr>
+          <a:xfrm xmlns:a="http://schemas.openxmlformats.org/drawingml/2006/main">
+            <a:off x="838200" y="365125"/>
+            <a:ext cx="10515600" cy="1320800"/>
+          </a:xfrm>
+        </p:spPr>
+        <p:txBody>
+          <a:bodyPr xmlns:a="http://schemas.openxmlformats.org/drawingml/2006/main"/>
+          <a:lstStyle xmlns:a="http://schemas.openxmlformats.org/drawingml/2006/main"/>
+          <a:p xmlns:a="http://schemas.openxmlformats.org/drawingml/2006/main">
+            <a:r>
+              <a:rPr lang="en-US" sz="3000" b="1">
+                <a:solidFill>
+                  <a:srgbClr val="FFFFFF"/>
+                </a:solidFill>
+              </a:rPr>
+              <a:t>7  Preflight before send</a:t>
+            </a:r>
+          </a:p>
+        </p:txBody>
+      </p:sp>
+      <p:sp>
+        <p:nvSpPr>
+          <p:cNvPr id="3" name="Content"/>
+          <p:cNvSpPr txBox="1"/>
+          <p:nvPr>
+            <p:ph type="body" idx="1"/>
+          </p:nvPr>
+        </p:nvSpPr>
+        <p:spPr>
+          <a:xfrm xmlns:a="http://schemas.openxmlformats.org/drawingml/2006/main">
+            <a:off x="838200" y="1825625"/>
+            <a:ext cx="10515600" cy="4349750"/>
+          </a:xfrm>
+        </p:spPr>
+        <p:txBody>
+          <a:bodyPr xmlns:a="http://schemas.openxmlformats.org/drawingml/2006/main"/>
+          <a:lstStyle xmlns:a="http://schemas.openxmlformats.org/drawingml/2006/main"/>
+          <a:p>
+            <a:r>
+              <a:rPr lang="en-US" sz="1800">
+                <a:solidFill>
+                  <a:srgbClr val="D9E7FF"/>
+                </a:solidFill>
+              </a:rPr>
+              <a:t>Every PDF is checked deterministically</a:t>
+            </a:r>
+          </a:p>
+          <a:p>
+            <a:r>
+              <a:rPr lang="en-US" sz="1800">
+                <a:solidFill>
+                  <a:srgbClr val="D9E7FF"/>
+                </a:solidFill>
+              </a:rPr>
+              <a:t/>
+            </a:r>
+          </a:p>
+          <a:p>
+            <a:r>
+              <a:rPr lang="en-US" sz="1800">
+                <a:solidFill>
+                  <a:srgbClr val="D9E7FF"/>
+                </a:solidFill>
+              </a:rPr>
+              <a:t>Text extractable  •  language correct</a:t>
+            </a:r>
+          </a:p>
+          <a:p>
+            <a:r>
+              <a:rPr lang="en-US" sz="1800">
+                <a:solidFill>
+                  <a:srgbClr val="D9E7FF"/>
+                </a:solidFill>
+              </a:rPr>
+              <a:t>Sections present  •  no blank pages</a:t>
+            </a:r>
+          </a:p>
+          <a:p>
+            <a:r>
+              <a:rPr lang="en-US" sz="1800">
+                <a:solidFill>
+                  <a:srgbClr val="D9E7FF"/>
+                </a:solidFill>
+              </a:rPr>
+              <a:t>No placeholders  •  correct document type</a:t>
+            </a:r>
+          </a:p>
+          <a:p>
+            <a:r>
+              <a:rPr lang="en-US" sz="1800">
+                <a:solidFill>
+                  <a:srgbClr val="D9E7FF"/>
+                </a:solidFill>
+              </a:rPr>
+              <a:t/>
+            </a:r>
+          </a:p>
+          <a:p>
+            <a:r>
+              <a:rPr lang="en-US" sz="1800">
+                <a:solidFill>
+                  <a:srgbClr val="D9E7FF"/>
+                </a:solidFill>
+              </a:rPr>
+              <a:t>Passed = Sendable</a:t>
+            </a:r>
+          </a:p>
+          <a:p>
+            <a:r>
+              <a:rPr lang="en-US" sz="1800">
+                <a:solidFill>
+                  <a:srgbClr val="D9E7FF"/>
+                </a:solidFill>
+              </a:rPr>
+              <a:t>Issues = Draft for review</a:t>
+            </a:r>
+          </a:p>
+          <a:p>
+            <a:r>
+              <a:rPr lang="en-US" sz="1800">
+                <a:solidFill>
+                  <a:srgbClr val="D9E7FF"/>
+                </a:solidFill>
+              </a:rPr>
+              <a:t/>
+            </a:r>
+          </a:p>
+          <a:p>
+            <a:r>
+              <a:rPr lang="en-US" sz="1800">
+                <a:solidFill>
+                  <a:srgbClr val="D9E7FF"/>
+                </a:solidFill>
+              </a:rPr>
+              <a:t>A better application is not just generated. It is ready.</a:t>
+            </a:r>
+          </a:p>
+        </p:txBody>
+      </p:sp>
+      <p:sp>
+        <p:nvSpPr>
+          <p:cNvPr id="100016" name="AccentBar9"/>
+          <p:cNvSpPr/>
+          <p:nvPr/>
+        </p:nvSpPr>
+        <p:spPr>
+          <a:xfrm>
+            <a:off x="0" y="0"/>
+            <a:ext cx="12191695" cy="109728"/>
+          </a:xfrm>
+          <a:prstGeom prst="rect">
+            <a:avLst/>
+          </a:prstGeom>
+          <a:solidFill>
+            <a:srgbClr val="22D3C5"/>
+          </a:solidFill>
+          <a:ln>
+            <a:noFill/>
+          </a:ln>
+        </p:spPr>
+        <p:txBody>
+          <a:bodyPr/>
+          <a:lstStyle/>
+          <a:p/>
+        </p:txBody>
+      </p:sp>
+      <p:sp>
+        <p:nvSpPr>
+          <p:cNvPr id="100017" name="Footer9"/>
+          <p:cNvSpPr txBox="1"/>
+          <p:nvPr/>
+        </p:nvSpPr>
+        <p:spPr>
+          <a:xfrm>
+            <a:off x="640080" y="6327648"/>
+            <a:ext cx="10972800" cy="320040"/>
+          </a:xfrm>
+          <a:prstGeom prst="rect">
+            <a:avLst/>
+          </a:prstGeom>
+          <a:solidFill>
+            <a:srgbClr val="000000">
+              <a:alpha val="0"/>
+            </a:srgbClr>
+          </a:solidFill>
+          <a:ln>
+            <a:noFill/>
+          </a:ln>
+        </p:spPr>
+        <p:txBody>
+          <a:bodyPr/>
+          <a:lstStyle/>
+          <a:p>
+            <a:r>
+              <a:rPr lang="en-US" sz="900">
+                <a:solidFill>
+                  <a:srgbClr val="8FA6C9"/>
+                </a:solidFill>
+              </a:rPr>
+              <a:t>JOBSEEKER V3  •  TRUST-FIRST APPLICATIONS</a:t>
+            </a:r>
+          </a:p>
+        </p:txBody>
+      </p:sp>
+    </p:spTree>
+  </p:cSld>
+  <p:transition>
+    <p:fade/>
+  </p:transition>
 </p:sld>
 </file>
 

</xml_diff>